<commit_message>
Add 説明会改善効果検証レポート (upper-tier universities only, 8 slides)
</commit_message>
<xml_diff>
--- a/説明会改善効果検証レポート_2026.pptx
+++ b/説明会改善効果検証レポート_2026.pptx
@@ -12,6 +12,7 @@
     <p:sldId id="260" r:id="rId11"/>
     <p:sldId id="261" r:id="rId12"/>
     <p:sldId id="262" r:id="rId13"/>
+    <p:sldId id="263" r:id="rId14"/>
   </p:sldIdLst>
   <p:sldSz cx="12193200" cy="6858000" type="screen4x3"/>
   <p:notesSz cx="6858000" cy="9144000"/>
@@ -3188,7 +3189,7 @@
         </p:nvSpPr>
         <p:spPr>
           <a:xfrm>
-            <a:off x="720000" y="1152000"/>
+            <a:off x="720000" y="1080000"/>
             <a:ext cx="10753200" cy="900000"/>
           </a:xfrm>
           <a:prstGeom prst="rect">
@@ -3223,7 +3224,7 @@
         </p:nvSpPr>
         <p:spPr>
           <a:xfrm>
-            <a:off x="720000" y="2232000"/>
+            <a:off x="720000" y="2160000"/>
             <a:ext cx="10753200" cy="540000"/>
           </a:xfrm>
           <a:prstGeom prst="rect">
@@ -3239,13 +3240,13 @@
           <a:p>
             <a:pPr algn="ctr"/>
             <a:r>
-              <a:rPr sz="2000" b="0">
+              <a:rPr sz="1900" b="0">
                 <a:solidFill>
                   <a:srgbClr val="CCDDFF"/>
                 </a:solidFill>
                 <a:latin typeface="IPAゴシック"/>
               </a:rPr>
-              <a:t>【27新卒】営業職　担当者・内容変更の前後比較</a:t>
+              <a:t>【27新卒】営業職　担当者・内容変更の前後比較（上位校限定）</a:t>
             </a:r>
           </a:p>
         </p:txBody>
@@ -3258,8 +3259,8 @@
         </p:nvSpPr>
         <p:spPr>
           <a:xfrm>
-            <a:off x="720000" y="2880000"/>
-            <a:ext cx="10753200" cy="540000"/>
+            <a:off x="720000" y="2700000"/>
+            <a:ext cx="10753200" cy="432000"/>
           </a:xfrm>
           <a:prstGeom prst="rect">
             <a:avLst/>
@@ -3274,7 +3275,42 @@
           <a:p>
             <a:pPr algn="ctr"/>
             <a:r>
-              <a:rPr sz="1600" b="0">
+              <a:rPr sz="1500" b="0">
+                <a:solidFill>
+                  <a:srgbClr val="99BBFF"/>
+                </a:solidFill>
+                <a:latin typeface="IPAゴシック"/>
+              </a:rPr>
+              <a:t>対象：GMARCH以上（旧帝大・早慶・上智理科ICU・GMARCH・関関同立）</a:t>
+            </a:r>
+          </a:p>
+        </p:txBody>
+      </p:sp>
+      <p:sp>
+        <p:nvSpPr>
+          <p:cNvPr id="7" name="TextBox 6"/>
+          <p:cNvSpPr txBox="1"/>
+          <p:nvPr/>
+        </p:nvSpPr>
+        <p:spPr>
+          <a:xfrm>
+            <a:off x="720000" y="3168000"/>
+            <a:ext cx="10753200" cy="432000"/>
+          </a:xfrm>
+          <a:prstGeom prst="rect">
+            <a:avLst/>
+          </a:prstGeom>
+          <a:noFill/>
+        </p:spPr>
+        <p:txBody>
+          <a:bodyPr wrap="square">
+            <a:spAutoFit/>
+          </a:bodyPr>
+          <a:lstStyle/>
+          <a:p>
+            <a:pPr algn="ctr"/>
+            <a:r>
+              <a:rPr sz="1400" b="0">
                 <a:solidFill>
                   <a:srgbClr val="AACCFF"/>
                 </a:solidFill>
@@ -3287,14 +3323,14 @@
       </p:sp>
       <p:sp>
         <p:nvSpPr>
-          <p:cNvPr id="7" name="Rectangle 6"/>
+          <p:cNvPr id="8" name="Rectangle 7"/>
           <p:cNvSpPr/>
           <p:nvPr/>
         </p:nvSpPr>
         <p:spPr>
           <a:xfrm>
-            <a:off x="360000" y="4031999"/>
-            <a:ext cx="2760300" cy="2196000"/>
+            <a:off x="360000" y="3960000"/>
+            <a:ext cx="2760300" cy="2268000"/>
           </a:xfrm>
           <a:prstGeom prst="rect">
             <a:avLst/>
@@ -3332,14 +3368,14 @@
       </p:sp>
       <p:sp>
         <p:nvSpPr>
-          <p:cNvPr id="8" name="TextBox 7"/>
+          <p:cNvPr id="9" name="TextBox 8"/>
           <p:cNvSpPr txBox="1"/>
           <p:nvPr/>
         </p:nvSpPr>
         <p:spPr>
           <a:xfrm>
-            <a:off x="468000" y="4140000"/>
-            <a:ext cx="2616301" cy="1980000"/>
+            <a:off x="468000" y="4068000"/>
+            <a:ext cx="2616301" cy="2052000"/>
           </a:xfrm>
           <a:prstGeom prst="rect">
             <a:avLst/>
@@ -3360,19 +3396,20 @@
                 </a:solidFill>
                 <a:latin typeface="IPAゴシック"/>
               </a:rPr>
-              <a:t>変更前 総応募</a:t>
+              <a:t>変更前
+上位校応募</a:t>
             </a:r>
           </a:p>
           <a:p>
             <a:pPr algn="ctr"/>
             <a:r>
-              <a:rPr sz="3000" b="1">
+              <a:rPr sz="3200" b="1">
                 <a:solidFill>
                   <a:srgbClr val="FFFFFF"/>
                 </a:solidFill>
                 <a:latin typeface="IPAゴシック"/>
               </a:rPr>
-              <a:t>19名</a:t>
+              <a:t>4名</a:t>
             </a:r>
           </a:p>
           <a:p>
@@ -3391,14 +3428,14 @@
       </p:sp>
       <p:sp>
         <p:nvSpPr>
-          <p:cNvPr id="9" name="Rectangle 8"/>
+          <p:cNvPr id="10" name="Rectangle 9"/>
           <p:cNvSpPr/>
           <p:nvPr/>
         </p:nvSpPr>
         <p:spPr>
           <a:xfrm>
-            <a:off x="3228300" y="4031999"/>
-            <a:ext cx="2760300" cy="2196000"/>
+            <a:off x="3228300" y="3960000"/>
+            <a:ext cx="2760300" cy="2268000"/>
           </a:xfrm>
           <a:prstGeom prst="rect">
             <a:avLst/>
@@ -3436,14 +3473,14 @@
       </p:sp>
       <p:sp>
         <p:nvSpPr>
-          <p:cNvPr id="10" name="TextBox 9"/>
+          <p:cNvPr id="11" name="TextBox 10"/>
           <p:cNvSpPr txBox="1"/>
           <p:nvPr/>
         </p:nvSpPr>
         <p:spPr>
           <a:xfrm>
-            <a:off x="3336300" y="4140000"/>
-            <a:ext cx="2616301" cy="1980000"/>
+            <a:off x="3336300" y="4068000"/>
+            <a:ext cx="2616301" cy="2052000"/>
           </a:xfrm>
           <a:prstGeom prst="rect">
             <a:avLst/>
@@ -3464,19 +3501,20 @@
                 </a:solidFill>
                 <a:latin typeface="IPAゴシック"/>
               </a:rPr>
-              <a:t>変更後 総応募</a:t>
+              <a:t>変更後
+上位校応募</a:t>
             </a:r>
           </a:p>
           <a:p>
             <a:pPr algn="ctr"/>
             <a:r>
-              <a:rPr sz="3000" b="1">
+              <a:rPr sz="3200" b="1">
                 <a:solidFill>
                   <a:srgbClr val="FFFFFF"/>
                 </a:solidFill>
                 <a:latin typeface="IPAゴシック"/>
               </a:rPr>
-              <a:t>379名</a:t>
+              <a:t>54名</a:t>
             </a:r>
           </a:p>
           <a:p>
@@ -3488,21 +3526,21 @@
                 </a:solidFill>
                 <a:latin typeface="IPAゴシック"/>
               </a:rPr>
-              <a:t>4/1〜現在</a:t>
-            </a:r>
-          </a:p>
-        </p:txBody>
-      </p:sp>
-      <p:sp>
-        <p:nvSpPr>
-          <p:cNvPr id="11" name="Rectangle 10"/>
+              <a:t>4/1〜現在（13.5倍）</a:t>
+            </a:r>
+          </a:p>
+        </p:txBody>
+      </p:sp>
+      <p:sp>
+        <p:nvSpPr>
+          <p:cNvPr id="12" name="Rectangle 11"/>
           <p:cNvSpPr/>
           <p:nvPr/>
         </p:nvSpPr>
         <p:spPr>
           <a:xfrm>
-            <a:off x="6096600" y="4031999"/>
-            <a:ext cx="2760300" cy="2196000"/>
+            <a:off x="6096600" y="3960000"/>
+            <a:ext cx="2760300" cy="2268000"/>
           </a:xfrm>
           <a:prstGeom prst="rect">
             <a:avLst/>
@@ -3540,14 +3578,14 @@
       </p:sp>
       <p:sp>
         <p:nvSpPr>
-          <p:cNvPr id="12" name="TextBox 11"/>
+          <p:cNvPr id="13" name="TextBox 12"/>
           <p:cNvSpPr txBox="1"/>
           <p:nvPr/>
         </p:nvSpPr>
         <p:spPr>
           <a:xfrm>
-            <a:off x="6204600" y="4140000"/>
-            <a:ext cx="2616301" cy="1980000"/>
+            <a:off x="6204600" y="4068000"/>
+            <a:ext cx="2616301" cy="2052000"/>
           </a:xfrm>
           <a:prstGeom prst="rect">
             <a:avLst/>
@@ -3568,14 +3606,14 @@
                 </a:solidFill>
                 <a:latin typeface="IPAゴシック"/>
               </a:rPr>
-              <a:t>変更後 説明会
-参加率</a:t>
+              <a:t>変更後
+説明会参加率</a:t>
             </a:r>
           </a:p>
           <a:p>
             <a:pPr algn="ctr"/>
             <a:r>
-              <a:rPr sz="3000" b="1">
+              <a:rPr sz="3200" b="1">
                 <a:solidFill>
                   <a:srgbClr val="FFFFFF"/>
                 </a:solidFill>
@@ -3593,21 +3631,21 @@
                 </a:solidFill>
                 <a:latin typeface="IPAゴシック"/>
               </a:rPr>
-              <a:t>44/54名 上位校</a:t>
-            </a:r>
-          </a:p>
-        </p:txBody>
-      </p:sp>
-      <p:sp>
-        <p:nvSpPr>
-          <p:cNvPr id="13" name="Rectangle 12"/>
+              <a:t>44/54名</a:t>
+            </a:r>
+          </a:p>
+        </p:txBody>
+      </p:sp>
+      <p:sp>
+        <p:nvSpPr>
+          <p:cNvPr id="14" name="Rectangle 13"/>
           <p:cNvSpPr/>
           <p:nvPr/>
         </p:nvSpPr>
         <p:spPr>
           <a:xfrm>
-            <a:off x="8964900" y="4031999"/>
-            <a:ext cx="2760300" cy="2196000"/>
+            <a:off x="8964900" y="3960000"/>
+            <a:ext cx="2760300" cy="2268000"/>
           </a:xfrm>
           <a:prstGeom prst="rect">
             <a:avLst/>
@@ -3645,14 +3683,14 @@
       </p:sp>
       <p:sp>
         <p:nvSpPr>
-          <p:cNvPr id="14" name="TextBox 13"/>
+          <p:cNvPr id="15" name="TextBox 14"/>
           <p:cNvSpPr txBox="1"/>
           <p:nvPr/>
         </p:nvSpPr>
         <p:spPr>
           <a:xfrm>
-            <a:off x="9072900" y="4140000"/>
-            <a:ext cx="2616301" cy="1980000"/>
+            <a:off x="9072900" y="4068000"/>
+            <a:ext cx="2616301" cy="2052000"/>
           </a:xfrm>
           <a:prstGeom prst="rect">
             <a:avLst/>
@@ -3673,14 +3711,14 @@
                 </a:solidFill>
                 <a:latin typeface="IPAゴシック"/>
               </a:rPr>
-              <a:t>変更後 説明会
-通過率</a:t>
+              <a:t>変更後
+説明会通過率</a:t>
             </a:r>
           </a:p>
           <a:p>
             <a:pPr algn="ctr"/>
             <a:r>
-              <a:rPr sz="3000" b="1">
+              <a:rPr sz="3200" b="1">
                 <a:solidFill>
                   <a:srgbClr val="FFFFFF"/>
                 </a:solidFill>
@@ -3837,7 +3875,7 @@
                 </a:solidFill>
                 <a:latin typeface="IPAゴシック"/>
               </a:rPr>
-              <a:t>説明会　変更概要（Before / After）</a:t>
+              <a:t>説明会　変更概要（Before / After）　上位校限定</a:t>
             </a:r>
           </a:p>
         </p:txBody>
@@ -3938,7 +3976,7 @@
         </p:nvSpPr>
         <p:spPr>
           <a:xfrm>
-            <a:off x="251999" y="972000"/>
+            <a:off x="252000" y="972000"/>
             <a:ext cx="5646600" cy="540000"/>
           </a:xfrm>
           <a:prstGeom prst="rect">
@@ -3973,8 +4011,8 @@
         </p:nvSpPr>
         <p:spPr>
           <a:xfrm>
-            <a:off x="288000" y="1692000"/>
-            <a:ext cx="2447172" cy="576000"/>
+            <a:off x="252000" y="1692000"/>
+            <a:ext cx="2330640" cy="576000"/>
           </a:xfrm>
           <a:prstGeom prst="rect">
             <a:avLst/>
@@ -4008,8 +4046,8 @@
         </p:nvSpPr>
         <p:spPr>
           <a:xfrm>
-            <a:off x="2793438" y="1692000"/>
-            <a:ext cx="3146364" cy="576000"/>
+            <a:off x="2699172" y="1692000"/>
+            <a:ext cx="3204630" cy="576000"/>
           </a:xfrm>
           <a:prstGeom prst="rect">
             <a:avLst/>
@@ -4024,7 +4062,7 @@
           <a:p>
             <a:pPr algn="l"/>
             <a:r>
-              <a:rPr sz="1400" b="1">
+              <a:rPr sz="1300" b="1">
                 <a:solidFill>
                   <a:srgbClr val="1F3564"/>
                 </a:solidFill>
@@ -4043,8 +4081,8 @@
         </p:nvSpPr>
         <p:spPr>
           <a:xfrm>
-            <a:off x="288000" y="2340000"/>
-            <a:ext cx="2447172" cy="576000"/>
+            <a:off x="252000" y="2329200"/>
+            <a:ext cx="2330640" cy="576000"/>
           </a:xfrm>
           <a:prstGeom prst="rect">
             <a:avLst/>
@@ -4078,8 +4116,8 @@
         </p:nvSpPr>
         <p:spPr>
           <a:xfrm>
-            <a:off x="2793438" y="2340000"/>
-            <a:ext cx="3146364" cy="576000"/>
+            <a:off x="2699172" y="2329200"/>
+            <a:ext cx="3204630" cy="576000"/>
           </a:xfrm>
           <a:prstGeom prst="rect">
             <a:avLst/>
@@ -4094,7 +4132,7 @@
           <a:p>
             <a:pPr algn="l"/>
             <a:r>
-              <a:rPr sz="1400" b="1">
+              <a:rPr sz="1300" b="1">
                 <a:solidFill>
                   <a:srgbClr val="1F3564"/>
                 </a:solidFill>
@@ -4113,8 +4151,8 @@
         </p:nvSpPr>
         <p:spPr>
           <a:xfrm>
-            <a:off x="288000" y="2988000"/>
-            <a:ext cx="2447172" cy="576000"/>
+            <a:off x="252000" y="2966400"/>
+            <a:ext cx="2330640" cy="576000"/>
           </a:xfrm>
           <a:prstGeom prst="rect">
             <a:avLst/>
@@ -4135,7 +4173,7 @@
                 </a:solidFill>
                 <a:latin typeface="IPAゴシック"/>
               </a:rPr>
-              <a:t>応募者数（全体）</a:t>
+              <a:t>上位校応募者</a:t>
             </a:r>
           </a:p>
         </p:txBody>
@@ -4148,8 +4186,8 @@
         </p:nvSpPr>
         <p:spPr>
           <a:xfrm>
-            <a:off x="2793438" y="2988000"/>
-            <a:ext cx="3146364" cy="576000"/>
+            <a:off x="2699172" y="2966400"/>
+            <a:ext cx="3204630" cy="576000"/>
           </a:xfrm>
           <a:prstGeom prst="rect">
             <a:avLst/>
@@ -4164,13 +4202,13 @@
           <a:p>
             <a:pPr algn="l"/>
             <a:r>
-              <a:rPr sz="1400" b="1">
+              <a:rPr sz="1300" b="1">
                 <a:solidFill>
                   <a:srgbClr val="1F3564"/>
                 </a:solidFill>
                 <a:latin typeface="IPAゴシック"/>
               </a:rPr>
-              <a:t>19名</a:t>
+              <a:t>4名（全19名中）</a:t>
             </a:r>
           </a:p>
         </p:txBody>
@@ -4183,8 +4221,8 @@
         </p:nvSpPr>
         <p:spPr>
           <a:xfrm>
-            <a:off x="288000" y="3636000"/>
-            <a:ext cx="2447172" cy="576000"/>
+            <a:off x="252000" y="3603600"/>
+            <a:ext cx="2330640" cy="576000"/>
           </a:xfrm>
           <a:prstGeom prst="rect">
             <a:avLst/>
@@ -4205,7 +4243,7 @@
                 </a:solidFill>
                 <a:latin typeface="IPAゴシック"/>
               </a:rPr>
-              <a:t>上位校応募者数</a:t>
+              <a:t>大学内訳</a:t>
             </a:r>
           </a:p>
         </p:txBody>
@@ -4218,8 +4256,8 @@
         </p:nvSpPr>
         <p:spPr>
           <a:xfrm>
-            <a:off x="2793438" y="3636000"/>
-            <a:ext cx="3146364" cy="576000"/>
+            <a:off x="2699172" y="3603600"/>
+            <a:ext cx="3204630" cy="576000"/>
           </a:xfrm>
           <a:prstGeom prst="rect">
             <a:avLst/>
@@ -4234,13 +4272,13 @@
           <a:p>
             <a:pPr algn="l"/>
             <a:r>
-              <a:rPr sz="1400" b="1">
+              <a:rPr sz="1300" b="1">
                 <a:solidFill>
                   <a:srgbClr val="1F3564"/>
                 </a:solidFill>
                 <a:latin typeface="IPAゴシック"/>
               </a:rPr>
-              <a:t>4名（21.1%）</a:t>
+              <a:t>関西学院大学×2、明治大学、同志社大学</a:t>
             </a:r>
           </a:p>
         </p:txBody>
@@ -4253,8 +4291,8 @@
         </p:nvSpPr>
         <p:spPr>
           <a:xfrm>
-            <a:off x="288000" y="4284000"/>
-            <a:ext cx="2447172" cy="576000"/>
+            <a:off x="252000" y="4240800"/>
+            <a:ext cx="2330640" cy="576000"/>
           </a:xfrm>
           <a:prstGeom prst="rect">
             <a:avLst/>
@@ -4288,8 +4326,8 @@
         </p:nvSpPr>
         <p:spPr>
           <a:xfrm>
-            <a:off x="2793438" y="4284000"/>
-            <a:ext cx="3146364" cy="576000"/>
+            <a:off x="2699172" y="4240800"/>
+            <a:ext cx="3204630" cy="576000"/>
           </a:xfrm>
           <a:prstGeom prst="rect">
             <a:avLst/>
@@ -4304,13 +4342,13 @@
           <a:p>
             <a:pPr algn="l"/>
             <a:r>
-              <a:rPr sz="1400" b="1">
+              <a:rPr sz="1300" b="1">
                 <a:solidFill>
                   <a:srgbClr val="1F3564"/>
                 </a:solidFill>
                 <a:latin typeface="IPAゴシック"/>
               </a:rPr>
-              <a:t>全員 選考中（結果未集計）</a:t>
+              <a:t>全員 選考中（結果集計中）</a:t>
             </a:r>
           </a:p>
         </p:txBody>
@@ -4323,8 +4361,8 @@
         </p:nvSpPr>
         <p:spPr>
           <a:xfrm>
-            <a:off x="288000" y="4932000"/>
-            <a:ext cx="2447172" cy="576000"/>
+            <a:off x="252000" y="4878000"/>
+            <a:ext cx="2330640" cy="576000"/>
           </a:xfrm>
           <a:prstGeom prst="rect">
             <a:avLst/>
@@ -4345,7 +4383,7 @@
                 </a:solidFill>
                 <a:latin typeface="IPAゴシック"/>
               </a:rPr>
-              <a:t>辞退者数</a:t>
+              <a:t>辞退</a:t>
             </a:r>
           </a:p>
         </p:txBody>
@@ -4358,8 +4396,8 @@
         </p:nvSpPr>
         <p:spPr>
           <a:xfrm>
-            <a:off x="2793438" y="4932000"/>
-            <a:ext cx="3146364" cy="576000"/>
+            <a:off x="2699172" y="4878000"/>
+            <a:ext cx="3204630" cy="576000"/>
           </a:xfrm>
           <a:prstGeom prst="rect">
             <a:avLst/>
@@ -4374,13 +4412,13 @@
           <a:p>
             <a:pPr algn="l"/>
             <a:r>
-              <a:rPr sz="1400" b="1">
+              <a:rPr sz="1300" b="1">
                 <a:solidFill>
                   <a:srgbClr val="1F3564"/>
                 </a:solidFill>
                 <a:latin typeface="IPAゴシック"/>
               </a:rPr>
-              <a:t>1名（実施前辞退のみ）</a:t>
+              <a:t>0名（全員参加予定）</a:t>
             </a:r>
           </a:p>
         </p:txBody>
@@ -4393,8 +4431,8 @@
         </p:nvSpPr>
         <p:spPr>
           <a:xfrm>
-            <a:off x="288000" y="5580000"/>
-            <a:ext cx="2447172" cy="576000"/>
+            <a:off x="252000" y="5515200"/>
+            <a:ext cx="2330640" cy="576000"/>
           </a:xfrm>
           <a:prstGeom prst="rect">
             <a:avLst/>
@@ -4428,8 +4466,8 @@
         </p:nvSpPr>
         <p:spPr>
           <a:xfrm>
-            <a:off x="2793438" y="5580000"/>
-            <a:ext cx="3146364" cy="576000"/>
+            <a:off x="2699172" y="5515200"/>
+            <a:ext cx="3204630" cy="576000"/>
           </a:xfrm>
           <a:prstGeom prst="rect">
             <a:avLst/>
@@ -4444,13 +4482,13 @@
           <a:p>
             <a:pPr algn="l"/>
             <a:r>
-              <a:rPr sz="1400" b="1">
+              <a:rPr sz="1300" b="1">
                 <a:solidFill>
                   <a:srgbClr val="1F3564"/>
                 </a:solidFill>
                 <a:latin typeface="IPAゴシック"/>
               </a:rPr>
-              <a:t>レバレジーズ：84.2%</a:t>
+              <a:t>レバレジーズ 4名（100%）</a:t>
             </a:r>
           </a:p>
         </p:txBody>
@@ -4587,7 +4625,7 @@
         <p:spPr>
           <a:xfrm>
             <a:off x="6150599" y="1692000"/>
-            <a:ext cx="2447172" cy="576000"/>
+            <a:ext cx="2330640" cy="576000"/>
           </a:xfrm>
           <a:prstGeom prst="rect">
             <a:avLst/>
@@ -4621,8 +4659,8 @@
         </p:nvSpPr>
         <p:spPr>
           <a:xfrm>
-            <a:off x="8656037" y="1692000"/>
-            <a:ext cx="3146364" cy="576000"/>
+            <a:off x="8597771" y="1692000"/>
+            <a:ext cx="3204630" cy="576000"/>
           </a:xfrm>
           <a:prstGeom prst="rect">
             <a:avLst/>
@@ -4637,7 +4675,7 @@
           <a:p>
             <a:pPr algn="l"/>
             <a:r>
-              <a:rPr sz="1400" b="1">
+              <a:rPr sz="1300" b="1">
                 <a:solidFill>
                   <a:srgbClr val="1F3564"/>
                 </a:solidFill>
@@ -4656,8 +4694,8 @@
         </p:nvSpPr>
         <p:spPr>
           <a:xfrm>
-            <a:off x="6150599" y="2340000"/>
-            <a:ext cx="2447172" cy="576000"/>
+            <a:off x="6150599" y="2329200"/>
+            <a:ext cx="2330640" cy="576000"/>
           </a:xfrm>
           <a:prstGeom prst="rect">
             <a:avLst/>
@@ -4691,8 +4729,8 @@
         </p:nvSpPr>
         <p:spPr>
           <a:xfrm>
-            <a:off x="8656037" y="2340000"/>
-            <a:ext cx="3146364" cy="576000"/>
+            <a:off x="8597771" y="2329200"/>
+            <a:ext cx="3204630" cy="576000"/>
           </a:xfrm>
           <a:prstGeom prst="rect">
             <a:avLst/>
@@ -4707,7 +4745,7 @@
           <a:p>
             <a:pPr algn="l"/>
             <a:r>
-              <a:rPr sz="1400" b="1">
+              <a:rPr sz="1300" b="1">
                 <a:solidFill>
                   <a:srgbClr val="1F3564"/>
                 </a:solidFill>
@@ -4726,8 +4764,8 @@
         </p:nvSpPr>
         <p:spPr>
           <a:xfrm>
-            <a:off x="6150599" y="2988000"/>
-            <a:ext cx="2447172" cy="576000"/>
+            <a:off x="6150599" y="2966400"/>
+            <a:ext cx="2330640" cy="576000"/>
           </a:xfrm>
           <a:prstGeom prst="rect">
             <a:avLst/>
@@ -4748,7 +4786,7 @@
                 </a:solidFill>
                 <a:latin typeface="IPAゴシック"/>
               </a:rPr>
-              <a:t>応募者数（全体）</a:t>
+              <a:t>上位校応募者</a:t>
             </a:r>
           </a:p>
         </p:txBody>
@@ -4761,8 +4799,8 @@
         </p:nvSpPr>
         <p:spPr>
           <a:xfrm>
-            <a:off x="8656037" y="2988000"/>
-            <a:ext cx="3146364" cy="576000"/>
+            <a:off x="8597771" y="2966400"/>
+            <a:ext cx="3204630" cy="576000"/>
           </a:xfrm>
           <a:prstGeom prst="rect">
             <a:avLst/>
@@ -4777,13 +4815,13 @@
           <a:p>
             <a:pPr algn="l"/>
             <a:r>
-              <a:rPr sz="1400" b="1">
+              <a:rPr sz="1300" b="1">
                 <a:solidFill>
                   <a:srgbClr val="1F3564"/>
                 </a:solidFill>
                 <a:latin typeface="IPAゴシック"/>
               </a:rPr>
-              <a:t>379名</a:t>
+              <a:t>54名（全379名中）</a:t>
             </a:r>
           </a:p>
         </p:txBody>
@@ -4796,8 +4834,8 @@
         </p:nvSpPr>
         <p:spPr>
           <a:xfrm>
-            <a:off x="6150599" y="3636000"/>
-            <a:ext cx="2447172" cy="576000"/>
+            <a:off x="6150599" y="3603600"/>
+            <a:ext cx="2330640" cy="576000"/>
           </a:xfrm>
           <a:prstGeom prst="rect">
             <a:avLst/>
@@ -4818,7 +4856,7 @@
                 </a:solidFill>
                 <a:latin typeface="IPAゴシック"/>
               </a:rPr>
-              <a:t>上位校応募者数</a:t>
+              <a:t>大学内訳</a:t>
             </a:r>
           </a:p>
         </p:txBody>
@@ -4831,8 +4869,8 @@
         </p:nvSpPr>
         <p:spPr>
           <a:xfrm>
-            <a:off x="8656037" y="3636000"/>
-            <a:ext cx="3146364" cy="576000"/>
+            <a:off x="8597771" y="3603600"/>
+            <a:ext cx="3204630" cy="576000"/>
           </a:xfrm>
           <a:prstGeom prst="rect">
             <a:avLst/>
@@ -4847,13 +4885,13 @@
           <a:p>
             <a:pPr algn="l"/>
             <a:r>
-              <a:rPr sz="1400" b="1">
+              <a:rPr sz="1300" b="1">
                 <a:solidFill>
                   <a:srgbClr val="1F3564"/>
                 </a:solidFill>
                 <a:latin typeface="IPAゴシック"/>
               </a:rPr>
-              <a:t>54名（14.2%）</a:t>
+              <a:t>関関同立・MARCH中心</a:t>
             </a:r>
           </a:p>
         </p:txBody>
@@ -4866,8 +4904,8 @@
         </p:nvSpPr>
         <p:spPr>
           <a:xfrm>
-            <a:off x="6150599" y="4284000"/>
-            <a:ext cx="2447172" cy="576000"/>
+            <a:off x="6150599" y="4240800"/>
+            <a:ext cx="2330640" cy="576000"/>
           </a:xfrm>
           <a:prstGeom prst="rect">
             <a:avLst/>
@@ -4888,7 +4926,7 @@
                 </a:solidFill>
                 <a:latin typeface="IPAゴシック"/>
               </a:rPr>
-              <a:t>説明会 参加率</a:t>
+              <a:t>説明会参加率</a:t>
             </a:r>
           </a:p>
         </p:txBody>
@@ -4901,8 +4939,8 @@
         </p:nvSpPr>
         <p:spPr>
           <a:xfrm>
-            <a:off x="8656037" y="4284000"/>
-            <a:ext cx="3146364" cy="576000"/>
+            <a:off x="8597771" y="4240800"/>
+            <a:ext cx="3204630" cy="576000"/>
           </a:xfrm>
           <a:prstGeom prst="rect">
             <a:avLst/>
@@ -4917,7 +4955,7 @@
           <a:p>
             <a:pPr algn="l"/>
             <a:r>
-              <a:rPr sz="1400" b="1">
+              <a:rPr sz="1300" b="1">
                 <a:solidFill>
                   <a:srgbClr val="1F3564"/>
                 </a:solidFill>
@@ -4936,8 +4974,8 @@
         </p:nvSpPr>
         <p:spPr>
           <a:xfrm>
-            <a:off x="6150599" y="4932000"/>
-            <a:ext cx="2447172" cy="576000"/>
+            <a:off x="6150599" y="4878000"/>
+            <a:ext cx="2330640" cy="576000"/>
           </a:xfrm>
           <a:prstGeom prst="rect">
             <a:avLst/>
@@ -4958,7 +4996,7 @@
                 </a:solidFill>
                 <a:latin typeface="IPAゴシック"/>
               </a:rPr>
-              <a:t>説明会 通過率</a:t>
+              <a:t>説明会通過率</a:t>
             </a:r>
           </a:p>
         </p:txBody>
@@ -4971,8 +5009,8 @@
         </p:nvSpPr>
         <p:spPr>
           <a:xfrm>
-            <a:off x="8656037" y="4932000"/>
-            <a:ext cx="3146364" cy="576000"/>
+            <a:off x="8597771" y="4878000"/>
+            <a:ext cx="3204630" cy="576000"/>
           </a:xfrm>
           <a:prstGeom prst="rect">
             <a:avLst/>
@@ -4987,7 +5025,7 @@
           <a:p>
             <a:pPr algn="l"/>
             <a:r>
-              <a:rPr sz="1400" b="1">
+              <a:rPr sz="1300" b="1">
                 <a:solidFill>
                   <a:srgbClr val="E85D5D"/>
                 </a:solidFill>
@@ -5006,8 +5044,8 @@
         </p:nvSpPr>
         <p:spPr>
           <a:xfrm>
-            <a:off x="6150599" y="5580000"/>
-            <a:ext cx="2447172" cy="576000"/>
+            <a:off x="6150599" y="5515200"/>
+            <a:ext cx="2330640" cy="576000"/>
           </a:xfrm>
           <a:prstGeom prst="rect">
             <a:avLst/>
@@ -5041,8 +5079,8 @@
         </p:nvSpPr>
         <p:spPr>
           <a:xfrm>
-            <a:off x="8656037" y="5580000"/>
-            <a:ext cx="3146364" cy="576000"/>
+            <a:off x="8597771" y="5515200"/>
+            <a:ext cx="3204630" cy="576000"/>
           </a:xfrm>
           <a:prstGeom prst="rect">
             <a:avLst/>
@@ -5057,13 +5095,13 @@
           <a:p>
             <a:pPr algn="l"/>
             <a:r>
-              <a:rPr sz="1400" b="1">
+              <a:rPr sz="1300" b="1">
                 <a:solidFill>
                   <a:srgbClr val="1F3564"/>
                 </a:solidFill>
                 <a:latin typeface="IPAゴシック"/>
               </a:rPr>
-              <a:t>レバレジーズ：84.4%</a:t>
+              <a:t>レバレジーズ 48名（88.9%）</a:t>
             </a:r>
           </a:p>
         </p:txBody>
@@ -5202,14 +5240,14 @@
                 </a:solidFill>
                 <a:latin typeface="IPAゴシック"/>
               </a:rPr>
-              <a:t>応募者数　変更前後比較</a:t>
+              <a:t>上位校 応募者数　変更前後比較</a:t>
             </a:r>
           </a:p>
         </p:txBody>
       </p:sp>
       <p:pic>
         <p:nvPicPr>
-          <p:cNvPr id="5" name="Picture 4" descr="応募数比較.png"/>
+          <p:cNvPr id="5" name="Picture 4" descr="応募数.png"/>
           <p:cNvPicPr>
             <a:picLocks noChangeAspect="1"/>
           </p:cNvPicPr>
@@ -5223,8 +5261,8 @@
         </p:blipFill>
         <p:spPr>
           <a:xfrm>
-            <a:off x="360000" y="936000"/>
-            <a:ext cx="11473200" cy="5778000"/>
+            <a:off x="1440000" y="936000"/>
+            <a:ext cx="9313200" cy="5778000"/>
           </a:xfrm>
           <a:prstGeom prst="rect">
             <a:avLst/>
@@ -5365,7 +5403,7 @@
                 </a:solidFill>
                 <a:latin typeface="IPAゴシック"/>
               </a:rPr>
-              <a:t>説明会　参加率・通過率　変更前後比較</a:t>
+              <a:t>説明会　参加率・通過率　変更前後比較（上位校）</a:t>
             </a:r>
           </a:p>
         </p:txBody>
@@ -5400,14 +5438,14 @@
                 </a:solidFill>
                 <a:latin typeface="IPAゴシック"/>
               </a:rPr>
-              <a:t>※変更前（1/1-3/31）は説明会 選考中のため参加率・通過率は集計中。変更後（4/1-現在）のデータで効果を測定。</a:t>
+              <a:t>※変更前（1/1-3/31）の上位校4名は説明会 選考中のため参加率・通過率は集計中。変更後（4/1-現在）の54名データで効果を測定。</a:t>
             </a:r>
           </a:p>
         </p:txBody>
       </p:sp>
       <p:pic>
         <p:nvPicPr>
-          <p:cNvPr id="6" name="Picture 5" descr="参加通過率比較.png"/>
+          <p:cNvPr id="6" name="Picture 5" descr="参加通過率.png"/>
           <p:cNvPicPr>
             <a:picLocks noChangeAspect="1"/>
           </p:cNvPicPr>
@@ -5570,7 +5608,7 @@
       </p:sp>
       <p:pic>
         <p:nvPicPr>
-          <p:cNvPr id="5" name="Picture 4" descr="ファネル後.png"/>
+          <p:cNvPr id="5" name="Picture 4" descr="ファネル.png"/>
           <p:cNvPicPr>
             <a:picLocks noChangeAspect="1"/>
           </p:cNvPicPr>
@@ -5585,7 +5623,7 @@
         <p:spPr>
           <a:xfrm>
             <a:off x="180000" y="972000"/>
-            <a:ext cx="7437852" cy="5634000"/>
+            <a:ext cx="7315920" cy="5634000"/>
           </a:xfrm>
           <a:prstGeom prst="rect">
             <a:avLst/>
@@ -5601,8 +5639,8 @@
           <p:nvPr/>
         </p:nvGraphicFramePr>
         <p:xfrm>
-          <a:off x="7559784" y="972000"/>
-          <a:ext cx="4389552" cy="5633999"/>
+          <a:off x="7437852" y="972000"/>
+          <a:ext cx="4511484" cy="5634000"/>
         </p:xfrm>
         <a:graphic>
           <a:graphicData uri="http://schemas.openxmlformats.org/drawingml/2006/table">
@@ -5611,11 +5649,11 @@
                 <a:tableStyleId>{5C22544A-7EE6-4342-B048-85BDC9FD1C3A}</a:tableStyleId>
               </a:tblPr>
               <a:tblGrid>
-                <a:gridCol w="2194776"/>
-                <a:gridCol w="1097388"/>
-                <a:gridCol w="1097388"/>
+                <a:gridCol w="2255742"/>
+                <a:gridCol w="1127871"/>
+                <a:gridCol w="1127871"/>
               </a:tblGrid>
-              <a:tr h="804857">
+              <a:tr h="704250">
                 <a:tc>
                   <a:txBody>
                     <a:bodyPr wrap="square"/>
@@ -5686,7 +5724,7 @@
                   </a:tcPr>
                 </a:tc>
               </a:tr>
-              <a:tr h="804857">
+              <a:tr h="704250">
                 <a:tc>
                   <a:txBody>
                     <a:bodyPr wrap="square"/>
@@ -5757,7 +5795,7 @@
                   </a:tcPr>
                 </a:tc>
               </a:tr>
-              <a:tr h="804857">
+              <a:tr h="704250">
                 <a:tc>
                   <a:txBody>
                     <a:bodyPr wrap="square"/>
@@ -5828,7 +5866,7 @@
                   </a:tcPr>
                 </a:tc>
               </a:tr>
-              <a:tr h="804857">
+              <a:tr h="704250">
                 <a:tc>
                   <a:txBody>
                     <a:bodyPr wrap="square"/>
@@ -5899,7 +5937,7 @@
                   </a:tcPr>
                 </a:tc>
               </a:tr>
-              <a:tr h="804857">
+              <a:tr h="704250">
                 <a:tc>
                   <a:txBody>
                     <a:bodyPr wrap="square"/>
@@ -5970,7 +6008,7 @@
                   </a:tcPr>
                 </a:tc>
               </a:tr>
-              <a:tr h="804857">
+              <a:tr h="704250">
                 <a:tc>
                   <a:txBody>
                     <a:bodyPr wrap="square"/>
@@ -6041,7 +6079,7 @@
                   </a:tcPr>
                 </a:tc>
               </a:tr>
-              <a:tr h="804857">
+              <a:tr h="704250">
                 <a:tc>
                   <a:txBody>
                     <a:bodyPr wrap="square"/>
@@ -6112,6 +6150,77 @@
                   </a:tcPr>
                 </a:tc>
               </a:tr>
+              <a:tr h="704250">
+                <a:tc>
+                  <a:txBody>
+                    <a:bodyPr wrap="square"/>
+                    <a:lstStyle/>
+                    <a:p>
+                      <a:pPr algn="ctr"/>
+                      <a:r>
+                        <a:rPr sz="1300" b="1">
+                          <a:solidFill>
+                            <a:srgbClr val="E85D5D"/>
+                          </a:solidFill>
+                          <a:latin typeface="IPAゴシック"/>
+                        </a:rPr>
+                        <a:t>実施前辞退</a:t>
+                      </a:r>
+                    </a:p>
+                  </a:txBody>
+                  <a:tcPr>
+                    <a:solidFill>
+                      <a:srgbClr val="FFF0F0"/>
+                    </a:solidFill>
+                  </a:tcPr>
+                </a:tc>
+                <a:tc>
+                  <a:txBody>
+                    <a:bodyPr wrap="square"/>
+                    <a:lstStyle/>
+                    <a:p>
+                      <a:pPr algn="ctr"/>
+                      <a:r>
+                        <a:rPr sz="1300" b="1">
+                          <a:solidFill>
+                            <a:srgbClr val="E85D5D"/>
+                          </a:solidFill>
+                          <a:latin typeface="IPAゴシック"/>
+                        </a:rPr>
+                        <a:t>10名</a:t>
+                      </a:r>
+                    </a:p>
+                  </a:txBody>
+                  <a:tcPr>
+                    <a:solidFill>
+                      <a:srgbClr val="FFF0F0"/>
+                    </a:solidFill>
+                  </a:tcPr>
+                </a:tc>
+                <a:tc>
+                  <a:txBody>
+                    <a:bodyPr wrap="square"/>
+                    <a:lstStyle/>
+                    <a:p>
+                      <a:pPr algn="ctr"/>
+                      <a:r>
+                        <a:rPr sz="1300" b="1">
+                          <a:solidFill>
+                            <a:srgbClr val="E85D5D"/>
+                          </a:solidFill>
+                          <a:latin typeface="IPAゴシック"/>
+                        </a:rPr>
+                        <a:t>18.5%</a:t>
+                      </a:r>
+                    </a:p>
+                  </a:txBody>
+                  <a:tcPr>
+                    <a:solidFill>
+                      <a:srgbClr val="FFF0F0"/>
+                    </a:solidFill>
+                  </a:tcPr>
+                </a:tc>
+              </a:tr>
             </a:tbl>
           </a:graphicData>
         </a:graphic>
@@ -6348,13 +6457,13 @@
           <a:p>
             <a:pPr algn="l"/>
             <a:r>
-              <a:rPr sz="1400" b="1">
+              <a:rPr sz="1300" b="1">
                 <a:solidFill>
                   <a:srgbClr val="276CAE"/>
                 </a:solidFill>
                 <a:latin typeface="IPAゴシック"/>
               </a:rPr>
-              <a:t>変更前（1/1-3/31）</a:t>
+              <a:t>変更前（1/1-3/31）上位校4名</a:t>
             </a:r>
           </a:p>
         </p:txBody>
@@ -6383,16 +6492,15 @@
           <a:p>
             <a:pPr algn="l"/>
             <a:r>
-              <a:rPr sz="1200" b="0">
+              <a:rPr sz="1300" b="0">
                 <a:solidFill>
                   <a:srgbClr val="1F3564"/>
                 </a:solidFill>
                 <a:latin typeface="IPAゴシック"/>
               </a:rPr>
-              <a:t>実施前辞退：1名
-実施後辞退：0名
-※説明会未実施のため
-　直接比較は限定的</a:t>
+              <a:t>辞退：0名
+全員 説明会 選考中
+（参加意向は100%）</a:t>
             </a:r>
           </a:p>
         </p:txBody>
@@ -6466,13 +6574,13 @@
           <a:p>
             <a:pPr algn="l"/>
             <a:r>
-              <a:rPr sz="1400" b="1">
+              <a:rPr sz="1300" b="1">
                 <a:solidFill>
                   <a:srgbClr val="27AE60"/>
                 </a:solidFill>
                 <a:latin typeface="IPAゴシック"/>
               </a:rPr>
-              <a:t>変更後（4/1-現在）</a:t>
+              <a:t>変更後（4/1-現在）上位校54名</a:t>
             </a:r>
           </a:p>
         </p:txBody>
@@ -6501,7 +6609,7 @@
           <a:p>
             <a:pPr algn="l"/>
             <a:r>
-              <a:rPr sz="1200" b="0">
+              <a:rPr sz="1300" b="0">
                 <a:solidFill>
                   <a:srgbClr val="1F3564"/>
                 </a:solidFill>
@@ -6509,8 +6617,7 @@
               </a:rPr>
               <a:t>実施前辞退：10名（18.5%）
 実施後辞退： 6名（11.1%）
-合計辞退　：16名（29.6%）
-→参加後辞退の原因分析が課題</a:t>
+合計辞退　：16名（29.6%）</a:t>
             </a:r>
           </a:p>
         </p:txBody>
@@ -6584,13 +6691,13 @@
           <a:p>
             <a:pPr algn="l"/>
             <a:r>
-              <a:rPr sz="1400" b="1">
+              <a:rPr sz="1300" b="1">
                 <a:solidFill>
                   <a:srgbClr val="F5A623"/>
                 </a:solidFill>
                 <a:latin typeface="IPAゴシック"/>
               </a:rPr>
-              <a:t>改善ポイント</a:t>
+              <a:t>次のアクション</a:t>
             </a:r>
           </a:p>
         </p:txBody>
@@ -6619,16 +6726,16 @@
           <a:p>
             <a:pPr algn="l"/>
             <a:r>
-              <a:rPr sz="1200" b="0">
+              <a:rPr sz="1300" b="0">
                 <a:solidFill>
                   <a:srgbClr val="1F3564"/>
                 </a:solidFill>
                 <a:latin typeface="IPAゴシック"/>
               </a:rPr>
-              <a:t>実施前辞退の削減：
+              <a:t>実施前辞退削減：
   応募前の情報提供を強化
-実施後辞退の削減：
-  説明会内容の精度向上</a:t>
+実施後辞退削減：
+  説明会内容・訴求力の改善</a:t>
             </a:r>
           </a:p>
         </p:txBody>
@@ -6709,6 +6816,169 @@
             <a:avLst/>
           </a:prstGeom>
           <a:solidFill>
+            <a:srgbClr val="1F3564"/>
+          </a:solidFill>
+          <a:ln>
+            <a:noFill/>
+          </a:ln>
+        </p:spPr>
+        <p:style>
+          <a:lnRef idx="1">
+            <a:schemeClr val="accent1"/>
+          </a:lnRef>
+          <a:fillRef idx="3">
+            <a:schemeClr val="accent1"/>
+          </a:fillRef>
+          <a:effectRef idx="2">
+            <a:schemeClr val="accent1"/>
+          </a:effectRef>
+          <a:fontRef idx="minor">
+            <a:schemeClr val="lt1"/>
+          </a:fontRef>
+        </p:style>
+        <p:txBody>
+          <a:bodyPr rtlCol="0" anchor="ctr"/>
+          <a:lstStyle/>
+          <a:p>
+            <a:pPr algn="ctr"/>
+          </a:p>
+        </p:txBody>
+      </p:sp>
+      <p:sp>
+        <p:nvSpPr>
+          <p:cNvPr id="4" name="TextBox 3"/>
+          <p:cNvSpPr txBox="1"/>
+          <p:nvPr/>
+        </p:nvSpPr>
+        <p:spPr>
+          <a:xfrm>
+            <a:off x="180000" y="0"/>
+            <a:ext cx="11833200" cy="792000"/>
+          </a:xfrm>
+          <a:prstGeom prst="rect">
+            <a:avLst/>
+          </a:prstGeom>
+          <a:noFill/>
+        </p:spPr>
+        <p:txBody>
+          <a:bodyPr wrap="none">
+            <a:spAutoFit/>
+          </a:bodyPr>
+          <a:lstStyle/>
+          <a:p>
+            <a:pPr algn="ctr"/>
+            <a:r>
+              <a:rPr sz="2500" b="1">
+                <a:solidFill>
+                  <a:srgbClr val="FFFFFF"/>
+                </a:solidFill>
+                <a:latin typeface="IPAゴシック"/>
+              </a:rPr>
+              <a:t>エージェント別 応募数　変更前後比較（上位校）</a:t>
+            </a:r>
+          </a:p>
+        </p:txBody>
+      </p:sp>
+      <p:pic>
+        <p:nvPicPr>
+          <p:cNvPr id="5" name="Picture 4" descr="エージェント.png"/>
+          <p:cNvPicPr>
+            <a:picLocks noChangeAspect="1"/>
+          </p:cNvPicPr>
+          <p:nvPr/>
+        </p:nvPicPr>
+        <p:blipFill>
+          <a:blip r:embed="rId2"/>
+          <a:stretch>
+            <a:fillRect/>
+          </a:stretch>
+        </p:blipFill>
+        <p:spPr>
+          <a:xfrm>
+            <a:off x="180000" y="972000"/>
+            <a:ext cx="11833200" cy="5634000"/>
+          </a:xfrm>
+          <a:prstGeom prst="rect">
+            <a:avLst/>
+          </a:prstGeom>
+        </p:spPr>
+      </p:pic>
+    </p:spTree>
+  </p:cSld>
+  <p:clrMapOvr>
+    <a:masterClrMapping/>
+  </p:clrMapOvr>
+</p:sld>
+</file>
+
+<file path=ppt/slides/slide8.xml><?xml version="1.0" encoding="utf-8"?>
+<p:sld xmlns:a="http://schemas.openxmlformats.org/drawingml/2006/main" xmlns:p="http://schemas.openxmlformats.org/presentationml/2006/main" xmlns:r="http://schemas.openxmlformats.org/officeDocument/2006/relationships">
+  <p:cSld>
+    <p:spTree>
+      <p:nvGrpSpPr>
+        <p:cNvPr id="1" name=""/>
+        <p:cNvGrpSpPr/>
+        <p:nvPr/>
+      </p:nvGrpSpPr>
+      <p:grpSpPr/>
+      <p:sp>
+        <p:nvSpPr>
+          <p:cNvPr id="2" name="Rectangle 1"/>
+          <p:cNvSpPr/>
+          <p:nvPr/>
+        </p:nvSpPr>
+        <p:spPr>
+          <a:xfrm>
+            <a:off x="0" y="0"/>
+            <a:ext cx="12193200" cy="6858000"/>
+          </a:xfrm>
+          <a:prstGeom prst="rect">
+            <a:avLst/>
+          </a:prstGeom>
+          <a:solidFill>
+            <a:srgbClr val="F4F6FB"/>
+          </a:solidFill>
+          <a:ln>
+            <a:noFill/>
+          </a:ln>
+        </p:spPr>
+        <p:style>
+          <a:lnRef idx="1">
+            <a:schemeClr val="accent1"/>
+          </a:lnRef>
+          <a:fillRef idx="3">
+            <a:schemeClr val="accent1"/>
+          </a:fillRef>
+          <a:effectRef idx="2">
+            <a:schemeClr val="accent1"/>
+          </a:effectRef>
+          <a:fontRef idx="minor">
+            <a:schemeClr val="lt1"/>
+          </a:fontRef>
+        </p:style>
+        <p:txBody>
+          <a:bodyPr rtlCol="0" anchor="ctr"/>
+          <a:lstStyle/>
+          <a:p>
+            <a:pPr algn="ctr"/>
+          </a:p>
+        </p:txBody>
+      </p:sp>
+      <p:sp>
+        <p:nvSpPr>
+          <p:cNvPr id="3" name="Rectangle 2"/>
+          <p:cNvSpPr/>
+          <p:nvPr/>
+        </p:nvSpPr>
+        <p:spPr>
+          <a:xfrm>
+            <a:off x="0" y="0"/>
+            <a:ext cx="12193200" cy="792000"/>
+          </a:xfrm>
+          <a:prstGeom prst="rect">
+            <a:avLst/>
+          </a:prstGeom>
+          <a:solidFill>
             <a:srgbClr val="6B1A1A"/>
           </a:solidFill>
           <a:ln>
@@ -6767,7 +7037,7 @@
                 </a:solidFill>
                 <a:latin typeface="IPAゴシック"/>
               </a:rPr>
-              <a:t>まとめ　と　次のアクション</a:t>
+              <a:t>まとめ　と　次のアクション（上位校視点）</a:t>
             </a:r>
           </a:p>
         </p:txBody>
@@ -6781,122 +7051,6 @@
         <p:spPr>
           <a:xfrm>
             <a:off x="144000" y="900000"/>
-            <a:ext cx="11905200" cy="1426500"/>
-          </a:xfrm>
-          <a:prstGeom prst="rect">
-            <a:avLst/>
-          </a:prstGeom>
-          <a:solidFill>
-            <a:srgbClr val="ECF0F8"/>
-          </a:solidFill>
-          <a:ln w="25400">
-            <a:solidFill>
-              <a:srgbClr val="1F3564"/>
-            </a:solidFill>
-          </a:ln>
-        </p:spPr>
-        <p:style>
-          <a:lnRef idx="1">
-            <a:schemeClr val="accent1"/>
-          </a:lnRef>
-          <a:fillRef idx="3">
-            <a:schemeClr val="accent1"/>
-          </a:fillRef>
-          <a:effectRef idx="2">
-            <a:schemeClr val="accent1"/>
-          </a:effectRef>
-          <a:fontRef idx="minor">
-            <a:schemeClr val="lt1"/>
-          </a:fontRef>
-        </p:style>
-        <p:txBody>
-          <a:bodyPr rtlCol="0" anchor="ctr"/>
-          <a:lstStyle/>
-          <a:p>
-            <a:pPr algn="ctr"/>
-          </a:p>
-        </p:txBody>
-      </p:sp>
-      <p:sp>
-        <p:nvSpPr>
-          <p:cNvPr id="6" name="TextBox 5"/>
-          <p:cNvSpPr txBox="1"/>
-          <p:nvPr/>
-        </p:nvSpPr>
-        <p:spPr>
-          <a:xfrm>
-            <a:off x="251999" y="972000"/>
-            <a:ext cx="3240000" cy="1354500"/>
-          </a:xfrm>
-          <a:prstGeom prst="rect">
-            <a:avLst/>
-          </a:prstGeom>
-          <a:noFill/>
-        </p:spPr>
-        <p:txBody>
-          <a:bodyPr wrap="square">
-            <a:spAutoFit/>
-          </a:bodyPr>
-          <a:lstStyle/>
-          <a:p>
-            <a:pPr algn="l"/>
-            <a:r>
-              <a:rPr sz="1600" b="1">
-                <a:solidFill>
-                  <a:srgbClr val="1F3564"/>
-                </a:solidFill>
-                <a:latin typeface="IPAゴシック"/>
-              </a:rPr>
-              <a:t>応募者数の変化</a:t>
-            </a:r>
-          </a:p>
-        </p:txBody>
-      </p:sp>
-      <p:sp>
-        <p:nvSpPr>
-          <p:cNvPr id="7" name="TextBox 6"/>
-          <p:cNvSpPr txBox="1"/>
-          <p:nvPr/>
-        </p:nvSpPr>
-        <p:spPr>
-          <a:xfrm>
-            <a:off x="3780000" y="972000"/>
-            <a:ext cx="8161201" cy="1354500"/>
-          </a:xfrm>
-          <a:prstGeom prst="rect">
-            <a:avLst/>
-          </a:prstGeom>
-          <a:noFill/>
-        </p:spPr>
-        <p:txBody>
-          <a:bodyPr wrap="square">
-            <a:spAutoFit/>
-          </a:bodyPr>
-          <a:lstStyle/>
-          <a:p>
-            <a:pPr algn="l"/>
-            <a:r>
-              <a:rPr sz="1300" b="0">
-                <a:solidFill>
-                  <a:srgbClr val="1F3564"/>
-                </a:solidFill>
-                <a:latin typeface="IPAゴシック"/>
-              </a:rPr>
-              <a:t>変更後（4/1〜）は変更前（1/1〜3/31）比で約20倍の応募者を獲得。
-上位校：4名→54名（13.5倍増）。採用母集団が大幅拡大。</a:t>
-            </a:r>
-          </a:p>
-        </p:txBody>
-      </p:sp>
-      <p:sp>
-        <p:nvSpPr>
-          <p:cNvPr id="8" name="Rectangle 7"/>
-          <p:cNvSpPr/>
-          <p:nvPr/>
-        </p:nvSpPr>
-        <p:spPr>
-          <a:xfrm>
-            <a:off x="144000" y="2362500"/>
             <a:ext cx="11905200" cy="1426500"/>
           </a:xfrm>
           <a:prstGeom prst="rect">
@@ -6935,14 +7089,14 @@
       </p:sp>
       <p:sp>
         <p:nvSpPr>
-          <p:cNvPr id="9" name="TextBox 8"/>
+          <p:cNvPr id="6" name="TextBox 5"/>
           <p:cNvSpPr txBox="1"/>
           <p:nvPr/>
         </p:nvSpPr>
         <p:spPr>
           <a:xfrm>
-            <a:off x="251999" y="2434500"/>
-            <a:ext cx="3240000" cy="1354500"/>
+            <a:off x="251999" y="972000"/>
+            <a:ext cx="3600000" cy="1354500"/>
           </a:xfrm>
           <a:prstGeom prst="rect">
             <a:avLst/>
@@ -6957,27 +7111,27 @@
           <a:p>
             <a:pPr algn="l"/>
             <a:r>
-              <a:rPr sz="1600" b="1">
+              <a:rPr sz="1500" b="1">
                 <a:solidFill>
                   <a:srgbClr val="27AE60"/>
                 </a:solidFill>
                 <a:latin typeface="IPAゴシック"/>
               </a:rPr>
-              <a:t>説明会参加率（変更後）</a:t>
-            </a:r>
-          </a:p>
-        </p:txBody>
-      </p:sp>
-      <p:sp>
-        <p:nvSpPr>
-          <p:cNvPr id="10" name="TextBox 9"/>
+              <a:t>応募者数：13.5倍増</a:t>
+            </a:r>
+          </a:p>
+        </p:txBody>
+      </p:sp>
+      <p:sp>
+        <p:nvSpPr>
+          <p:cNvPr id="7" name="TextBox 6"/>
           <p:cNvSpPr txBox="1"/>
           <p:nvPr/>
         </p:nvSpPr>
         <p:spPr>
           <a:xfrm>
-            <a:off x="3780000" y="2434500"/>
-            <a:ext cx="8161201" cy="1354500"/>
+            <a:off x="3960000" y="972000"/>
+            <a:ext cx="8053200" cy="1354500"/>
           </a:xfrm>
           <a:prstGeom prst="rect">
             <a:avLst/>
@@ -6998,21 +7152,21 @@
                 </a:solidFill>
                 <a:latin typeface="IPAゴシック"/>
               </a:rPr>
-              <a:t>上位校の参加率は81.5%（44/54名）。
-実施前辞退10名（18.5%）の削減が次の優先課題。</a:t>
-            </a:r>
-          </a:p>
-        </p:txBody>
-      </p:sp>
-      <p:sp>
-        <p:nvSpPr>
-          <p:cNvPr id="11" name="Rectangle 10"/>
+              <a:t>変更後（4/1〜）の上位校応募者は54名。変更前（1/1〜3/31）の4名から13.5倍に拡大。
+採用母集団の拡大という観点では大きな改善。</a:t>
+            </a:r>
+          </a:p>
+        </p:txBody>
+      </p:sp>
+      <p:sp>
+        <p:nvSpPr>
+          <p:cNvPr id="8" name="Rectangle 7"/>
           <p:cNvSpPr/>
           <p:nvPr/>
         </p:nvSpPr>
         <p:spPr>
           <a:xfrm>
-            <a:off x="144000" y="3825000"/>
+            <a:off x="144000" y="2362500"/>
             <a:ext cx="11905200" cy="1426500"/>
           </a:xfrm>
           <a:prstGeom prst="rect">
@@ -7051,14 +7205,14 @@
       </p:sp>
       <p:sp>
         <p:nvSpPr>
-          <p:cNvPr id="12" name="TextBox 11"/>
+          <p:cNvPr id="9" name="TextBox 8"/>
           <p:cNvSpPr txBox="1"/>
           <p:nvPr/>
         </p:nvSpPr>
         <p:spPr>
           <a:xfrm>
-            <a:off x="251999" y="3897000"/>
-            <a:ext cx="3240000" cy="1354500"/>
+            <a:off x="251999" y="2434500"/>
+            <a:ext cx="3600000" cy="1354500"/>
           </a:xfrm>
           <a:prstGeom prst="rect">
             <a:avLst/>
@@ -7073,27 +7227,27 @@
           <a:p>
             <a:pPr algn="l"/>
             <a:r>
-              <a:rPr sz="1600" b="1">
+              <a:rPr sz="1500" b="1">
                 <a:solidFill>
                   <a:srgbClr val="F5A623"/>
                 </a:solidFill>
                 <a:latin typeface="IPAゴシック"/>
               </a:rPr>
-              <a:t>説明会通過率（変更後）</a:t>
-            </a:r>
-          </a:p>
-        </p:txBody>
-      </p:sp>
-      <p:sp>
-        <p:nvSpPr>
-          <p:cNvPr id="13" name="TextBox 12"/>
+              <a:t>説明会参加率：81.5%（変更後）</a:t>
+            </a:r>
+          </a:p>
+        </p:txBody>
+      </p:sp>
+      <p:sp>
+        <p:nvSpPr>
+          <p:cNvPr id="10" name="TextBox 9"/>
           <p:cNvSpPr txBox="1"/>
           <p:nvPr/>
         </p:nvSpPr>
         <p:spPr>
           <a:xfrm>
-            <a:off x="3780000" y="3897000"/>
-            <a:ext cx="8161201" cy="1354500"/>
+            <a:off x="3960000" y="2434500"/>
+            <a:ext cx="8053200" cy="1354500"/>
           </a:xfrm>
           <a:prstGeom prst="rect">
             <a:avLst/>
@@ -7114,8 +7268,124 @@
                 </a:solidFill>
                 <a:latin typeface="IPAゴシック"/>
               </a:rPr>
-              <a:t>参加者中の通過率は56.8%（25/44名）。参加した候補者の半数以上が通過。
-説明会の質は一定水準を確保。</a:t>
+              <a:t>上位校54名中44名が説明会に参加（81.5%）。
+実施前辞退10名（18.5%）の削減が優先課題。説明会前の候補者へのフォローアップ強化を推奨。</a:t>
+            </a:r>
+          </a:p>
+        </p:txBody>
+      </p:sp>
+      <p:sp>
+        <p:nvSpPr>
+          <p:cNvPr id="11" name="Rectangle 10"/>
+          <p:cNvSpPr/>
+          <p:nvPr/>
+        </p:nvSpPr>
+        <p:spPr>
+          <a:xfrm>
+            <a:off x="144000" y="3825000"/>
+            <a:ext cx="11905200" cy="1426500"/>
+          </a:xfrm>
+          <a:prstGeom prst="rect">
+            <a:avLst/>
+          </a:prstGeom>
+          <a:solidFill>
+            <a:srgbClr val="ECF0F8"/>
+          </a:solidFill>
+          <a:ln w="25400">
+            <a:solidFill>
+              <a:srgbClr val="276CAE"/>
+            </a:solidFill>
+          </a:ln>
+        </p:spPr>
+        <p:style>
+          <a:lnRef idx="1">
+            <a:schemeClr val="accent1"/>
+          </a:lnRef>
+          <a:fillRef idx="3">
+            <a:schemeClr val="accent1"/>
+          </a:fillRef>
+          <a:effectRef idx="2">
+            <a:schemeClr val="accent1"/>
+          </a:effectRef>
+          <a:fontRef idx="minor">
+            <a:schemeClr val="lt1"/>
+          </a:fontRef>
+        </p:style>
+        <p:txBody>
+          <a:bodyPr rtlCol="0" anchor="ctr"/>
+          <a:lstStyle/>
+          <a:p>
+            <a:pPr algn="ctr"/>
+          </a:p>
+        </p:txBody>
+      </p:sp>
+      <p:sp>
+        <p:nvSpPr>
+          <p:cNvPr id="12" name="TextBox 11"/>
+          <p:cNvSpPr txBox="1"/>
+          <p:nvPr/>
+        </p:nvSpPr>
+        <p:spPr>
+          <a:xfrm>
+            <a:off x="251999" y="3897000"/>
+            <a:ext cx="3600000" cy="1354500"/>
+          </a:xfrm>
+          <a:prstGeom prst="rect">
+            <a:avLst/>
+          </a:prstGeom>
+          <a:noFill/>
+        </p:spPr>
+        <p:txBody>
+          <a:bodyPr wrap="square">
+            <a:spAutoFit/>
+          </a:bodyPr>
+          <a:lstStyle/>
+          <a:p>
+            <a:pPr algn="l"/>
+            <a:r>
+              <a:rPr sz="1500" b="1">
+                <a:solidFill>
+                  <a:srgbClr val="276CAE"/>
+                </a:solidFill>
+                <a:latin typeface="IPAゴシック"/>
+              </a:rPr>
+              <a:t>説明会通過率：56.8%（変更後）</a:t>
+            </a:r>
+          </a:p>
+        </p:txBody>
+      </p:sp>
+      <p:sp>
+        <p:nvSpPr>
+          <p:cNvPr id="13" name="TextBox 12"/>
+          <p:cNvSpPr txBox="1"/>
+          <p:nvPr/>
+        </p:nvSpPr>
+        <p:spPr>
+          <a:xfrm>
+            <a:off x="3960000" y="3897000"/>
+            <a:ext cx="8053200" cy="1354500"/>
+          </a:xfrm>
+          <a:prstGeom prst="rect">
+            <a:avLst/>
+          </a:prstGeom>
+          <a:noFill/>
+        </p:spPr>
+        <p:txBody>
+          <a:bodyPr wrap="square">
+            <a:spAutoFit/>
+          </a:bodyPr>
+          <a:lstStyle/>
+          <a:p>
+            <a:pPr algn="l"/>
+            <a:r>
+              <a:rPr sz="1300" b="0">
+                <a:solidFill>
+                  <a:srgbClr val="1F3564"/>
+                </a:solidFill>
+                <a:latin typeface="IPAゴシック"/>
+              </a:rPr>
+              <a:t>参加44名中25名が通過（56.8%）。参加者の過半数が次のステップへ進む水準。
+一次→最終の通過率（44%・9%）の改善も継続課題。</a:t>
             </a:r>
           </a:p>
         </p:txBody>
@@ -7174,7 +7444,7 @@
         <p:spPr>
           <a:xfrm>
             <a:off x="251999" y="5359500"/>
-            <a:ext cx="3240000" cy="1354500"/>
+            <a:ext cx="3600000" cy="1354500"/>
           </a:xfrm>
           <a:prstGeom prst="rect">
             <a:avLst/>
@@ -7189,13 +7459,13 @@
           <a:p>
             <a:pPr algn="l"/>
             <a:r>
-              <a:rPr sz="1600" b="1">
+              <a:rPr sz="1500" b="1">
                 <a:solidFill>
                   <a:srgbClr val="E85D5D"/>
                 </a:solidFill>
                 <a:latin typeface="IPAゴシック"/>
               </a:rPr>
-              <a:t>変更前データの評価</a:t>
+              <a:t>変更前の評価（集計中）</a:t>
             </a:r>
           </a:p>
         </p:txBody>
@@ -7208,8 +7478,8 @@
         </p:nvSpPr>
         <p:spPr>
           <a:xfrm>
-            <a:off x="3780000" y="5359500"/>
-            <a:ext cx="8161201" cy="1354500"/>
+            <a:off x="3960000" y="5359500"/>
+            <a:ext cx="8053200" cy="1354500"/>
           </a:xfrm>
           <a:prstGeom prst="rect">
             <a:avLst/>
@@ -7230,8 +7500,8 @@
                 </a:solidFill>
                 <a:latin typeface="IPAゴシック"/>
               </a:rPr>
-              <a:t>変更前（1/1-3/31）の19名はまだ説明会選考中。
-結果確定後に参加率・通過率の直接比較が可能になる。</a:t>
+              <a:t>変更前（1/1-3/31）の上位校4名は現在も説明会 選考中。
+結果確定後に参加率・通過率の直接比較が可能。定期的なデータ更新を推奨。</a:t>
             </a:r>
           </a:p>
         </p:txBody>

</xml_diff>